<commit_message>
Final-gate fixes for the 28.06 mid-presentation
- Slide 2: 41 -> 42 variables (the locked CSV snapshot includes 'Sanctioned');
  gloss Total/Dots/Tested; add a data-challenges bullet (instructor's explicit ask).
- Slide 3: add the 30-second powerlifting brief the instructor requested for
  sports datasets (3 lifts, 3 attempts, bodyweight classes).
- Slide 5: 'nested' -> 'generalized (GLRT) for nested models' terminology fix.
- Slide 7: state the analysis subsample (men, IPF+USAPL); future work = formal
  McCrary only (de-heaping already applied to the +1.92).
- Slide 9: future falsification spelled out (placebos, dose-response).
- fig_quantization: y-axis headroom so the annotation box no longer occludes
  the tallest (140 kg) bar.
</commit_message>
<xml_diff>
--- a/presentation/mid_presentation_OpenPowerlifting.pptx
+++ b/presentation/mid_presentation_OpenPowerlifting.pptx
@@ -3334,7 +3334,7 @@
                 </a:solidFill>
                 <a:latin typeface="Arial"/>
               </a:rPr>
-              <a:t>•  היקף: כ-3.94 מיליון תוצאות (שורה לכל מתחרה בכל תחרות), 41 משתנים.</a:t>
+              <a:t>•  היקף: כ-3.94 מיליון תוצאות (שורה לכל מתחרה בכל תחרות), 42 משתנים.</a:t>
             </a:r>
           </a:p>
           <a:p>
@@ -3350,7 +3350,23 @@
                 </a:solidFill>
                 <a:latin typeface="Arial"/>
               </a:rPr>
-              <a:t>•  משתנים: רציפים - משקל-גוף, משקלי-ניסיון, Total, Dots; קטגוריים - מין, ציוד, פדרציה, מקטע-משקל, Tested.</a:t>
+              <a:t>•  משתנים: רציפים - משקל-גוף, משקלי-ניסיון, Total (סכום שלוש ההרמות), Dots (ציון כוח מנורמל); קטגוריים - מין, ציוד, פדרציה, מקטע-משקל, Tested (תחרות עם בדיקות סמים).</a:t>
+            </a:r>
+          </a:p>
+          <a:p>
+            <a:pPr rtl="1" algn="r">
+              <a:spcAft>
+                <a:spcPts val="1200"/>
+              </a:spcAft>
+            </a:pPr>
+            <a:r>
+              <a:rPr sz="1900" b="0">
+                <a:solidFill>
+                  <a:srgbClr val="222222"/>
+                </a:solidFill>
+                <a:latin typeface="Arial"/>
+              </a:rPr>
+              <a:t>•  אתגרים בדאטה: אותו מתחרה מופיע בתחרויות רבות (תלות בין שורות), הבדלי סכמות בין פדרציות, והמרות lb→kg.</a:t>
             </a:r>
           </a:p>
           <a:p>
@@ -3522,6 +3538,22 @@
                 </a:solidFill>
                 <a:latin typeface="Arial"/>
               </a:rPr>
+              <a:t>•  רקע קצר: בהרמת-כוח שלוש הרמות (סקוואט, בנץ'-פרס, דדליפט), שלושה ניסיונות לכל הרמה, והתחרות נערכת בתוך מקטעי משקל-גוף.</a:t>
+            </a:r>
+          </a:p>
+          <a:p>
+            <a:pPr rtl="1" algn="r">
+              <a:spcAft>
+                <a:spcPts val="1200"/>
+              </a:spcAft>
+            </a:pPr>
+            <a:r>
+              <a:rPr sz="1900" b="0">
+                <a:solidFill>
+                  <a:srgbClr val="222222"/>
+                </a:solidFill>
+                <a:latin typeface="Arial"/>
+              </a:rPr>
               <a:t>•  מתחרה שולט בשני מספרים בלבד: המשקל על המוט (בחירת הניסיונות) ומשקל הגוף (בשקילה).</a:t>
             </a:r>
           </a:p>
@@ -3898,7 +3930,7 @@
                 </a:solidFill>
                 <a:latin typeface="Arial"/>
               </a:rPr>
-              <a:t>•  H1 (רשת המשקלים): מודל נראות עם עיגול-רשת (rounded-likelihood MLE) + מבחן יחס-נראות מקונן (GLRT).</a:t>
+              <a:t>•  H1 (רשת המשקלים): מודל נראות עם עיגול-רשת (rounded-likelihood MLE) + מבחן יחס-נראות מוכלל (GLRT) למודלים מקוננים.</a:t>
             </a:r>
           </a:p>
           <a:p>
@@ -4250,7 +4282,7 @@
                 </a:solidFill>
                 <a:latin typeface="Arial"/>
               </a:rPr>
-              <a:t>מתחת לסף 83 ק"ג (מחלקת IPF) הצטברות בולטת (יחס-לוג +1.92, שורד ניקוי מספרים-עגולים); בנקודת-בקרה שאינה סף (91 ק"ג) אין עודף (≈ -0.21). אינדיקציה ראשונית לחיתוך-משקל; אישוש פורמלי (McCrary, de-heaping) בהמשך.</a:t>
+              <a:t>מתחת לסף 83 ק"ג (מחלקת IPF; גברים, IPF+USAPL) הצטברות בולטת (יחס-לוג +1.92, שורד ניקוי מספרים-עגולים); בנקודת-בקרה שאינה סף (91 ק"ג) אין עודף (≈ -0.21). אינדיקציה ראשונית לחיתוך-משקל; מבחן McCrary פורמלי בהמשך.</a:t>
             </a:r>
           </a:p>
         </p:txBody>
@@ -4610,7 +4642,7 @@
                 </a:solidFill>
                 <a:latin typeface="Arial"/>
               </a:rPr>
-              <a:t>•  הצעדים הבאים: מבחן McCrary פורמלי + de-heaping, מבנה התפלגות הכוח, ואומדן תקרת-כוח (EVT).</a:t>
+              <a:t>•  הצעדים הבאים: מבחן McCrary פורמלי + בדיקות הפרכה מלאות (פלצבו, מינון-תגובה), מבנה התפלגות הכוח, ואומדן תקרת-כוח (EVT).</a:t>
             </a:r>
           </a:p>
           <a:p>

</xml_diff>

<commit_message>
Deck: remove all em-dashes, naturalize Hebrew (match the exemplar's style)
The exemplar mid-presentation (Animal Adoption) uses zero em-dashes; ours had ~15.
Replaced every "—" with natural punctuation (colon to introduce, comma for a pause,
parentheses for asides), and de-jargoned slide 2 (dropped the arrow + "dedup"/"snapshot"
in favour of plain Hebrew). No content/number changes.
</commit_message>
<xml_diff>
--- a/presentation/mid_presentation_OpenPowerlifting.pptx
+++ b/presentation/mid_presentation_OpenPowerlifting.pptx
@@ -3190,7 +3190,7 @@
                 </a:solidFill>
                 <a:latin typeface="Arial"/>
               </a:rPr>
-              <a:t>ניתוח סטטיסטי של OpenPowerlifting — מה הנתונים חושפים על גבולות הכוח</a:t>
+              <a:t>ניתוח סטטיסטי של OpenPowerlifting: מה הנתונים חושפים על גבולות הכוח</a:t>
             </a:r>
           </a:p>
           <a:p>
@@ -3238,7 +3238,7 @@
                 </a:solidFill>
                 <a:latin typeface="Arial"/>
               </a:rPr>
-              <a:t>תאוריה סטטיסטית · פרויקט סוף — מצגת אמצע</a:t>
+              <a:t>תאוריה סטטיסטית · פרויקט סוף · מצגת אמצע</a:t>
             </a:r>
           </a:p>
         </p:txBody>
@@ -3461,7 +3461,7 @@
                 </a:solidFill>
                 <a:latin typeface="Arial"/>
               </a:rPr>
-              <a:t>•  מקור: OpenPowerlifting — מאגר פתוח של תוצאות תחרויות הרמת-כוח (רישיון CC0).</a:t>
+              <a:t>•  מקור: OpenPowerlifting, מאגר פתוח של תוצאות תחרויות הרמת-כוח (רישיון CC0).</a:t>
             </a:r>
           </a:p>
           <a:p>
@@ -3493,7 +3493,7 @@
                 </a:solidFill>
                 <a:latin typeface="Arial"/>
               </a:rPr>
-              <a:t>•  משתנים: רציפים — משקל-גוף, משקלי-ניסיון, Total, Dots; קטגוריים — מין, ציוד, פדרציה, קטגוריית-משקל, Tested.</a:t>
+              <a:t>•  משתנים רציפים: משקל-גוף, משקלי-ניסיון, Total, Dots. משתנים קטגוריים: מין, ציוד, פדרציה, קטגוריית-משקל, Tested.</a:t>
             </a:r>
           </a:p>
           <a:p>
@@ -3509,7 +3509,7 @@
                 </a:solidFill>
                 <a:latin typeface="Arial"/>
               </a:rPr>
-              <a:t>•  אתגרים וטיפול: אותו מתחרה מופיע בכמה תחרויות (תלות בין שורות) → המבחנים הפורמליים ירוצו עם dedup לפי-מתחרה; התוצאות הראשוניות כאן ברמת-ניסיון/שורה. נועלים snapshot של הנתונים לשחזור.</a:t>
+              <a:t>•  אתגרים וטיפול: אותו מתחרה מופיע בכמה תחרויות (תלות בין שורות), ולכן המבחנים הפורמליים ירוצו עם שורה אחת לכל מתחרה; התוצאות הראשוניות כאן הן ברמת ניסיון בודד. שומרים גרסת-נתונים קבועה לשחזור.</a:t>
             </a:r>
           </a:p>
         </p:txBody>
@@ -3688,7 +3688,7 @@
                 </a:solidFill>
                 <a:latin typeface="Arial"/>
               </a:rPr>
-              <a:t>הרעיון: שני המספרים שהמתחרה שולט בהם — המוט והמאזניים</a:t>
+              <a:t>הרעיון: שני המספרים שהמתחרה שולט בהם, המוט והמאזניים</a:t>
             </a:r>
           </a:p>
           <a:p>
@@ -3736,7 +3736,7 @@
                 </a:solidFill>
                 <a:latin typeface="Arial"/>
               </a:rPr>
-              <a:t>•  התרומה: לא רק לתאר — אלא מודל-הסתברות מקורי לרשת-המשקלים, ומבחן-מניפולציה עם נקודת-בקרה ו-de-heaping.</a:t>
+              <a:t>•  התרומה: לא רק לתאר, אלא מודל-הסתברות מקורי לרשת-המשקלים, ומבחן-מניפולציה עם נקודת-בקרה ו-de-heaping.</a:t>
             </a:r>
           </a:p>
         </p:txBody>
@@ -3915,7 +3915,7 @@
                 </a:solidFill>
                 <a:latin typeface="Arial"/>
               </a:rPr>
-              <a:t>ארבע השערות, סיפור אחד — H1/H2 "שני המספרים", ו-H3/H4 גבולות-הכוח והניבוי</a:t>
+              <a:t>ארבע השערות, סיפור אחד: H1/H2 הם "שני המספרים", H3/H4 הם גבולות-הכוח והניבוי</a:t>
             </a:r>
           </a:p>
           <a:p>
@@ -3931,7 +3931,7 @@
                 </a:solidFill>
                 <a:latin typeface="Arial"/>
               </a:rPr>
-              <a:t>•  כיצד מתבטאת בנתונים ההתנהגות ה"מחושבת" של מתחרים — בבחירת המשקל על המוט ובמשקל הגוף?</a:t>
+              <a:t>•  כיצד מתבטאת בנתונים ההתנהגות ה"מחושבת" של מתחרים בבחירת המשקל על המוט ובמשקל הגוף?</a:t>
             </a:r>
           </a:p>
           <a:p>
@@ -3947,7 +3947,7 @@
                 </a:solidFill>
                 <a:latin typeface="Arial"/>
               </a:rPr>
-              <a:t>◦  H1 — משקלי הניסיון אינם רציפים אלא נופלים רק על רשת 2.5 ק"ג.</a:t>
+              <a:t>◦  H1: משקלי הניסיון אינם רציפים אלא נופלים רק על רשת 2.5 ק"ג.</a:t>
             </a:r>
           </a:p>
           <a:p>
@@ -3963,7 +3963,7 @@
                 </a:solidFill>
                 <a:latin typeface="Arial"/>
               </a:rPr>
-              <a:t>◦  H2 — הצטברות משקל-גוף ממש מתחת לסף קטגוריית-המשקל (עקבי עם חיתוך-משקל).</a:t>
+              <a:t>◦  H2: הצטברות משקל-גוף ממש מתחת לסף קטגוריית-המשקל (עקבי עם חיתוך-משקל).</a:t>
             </a:r>
           </a:p>
           <a:p>
@@ -3979,7 +3979,7 @@
                 </a:solidFill>
                 <a:latin typeface="Arial"/>
               </a:rPr>
-              <a:t>◦  H3 — קנה-המידה האלומטרי (כוח מול משקל-גוף) שונה בין המינים.</a:t>
+              <a:t>◦  H3: קנה-המידה האלומטרי (כוח מול משקל-גוף) שונה בין המינים.</a:t>
             </a:r>
           </a:p>
           <a:p>
@@ -3995,7 +3995,7 @@
                 </a:solidFill>
                 <a:latin typeface="Arial"/>
               </a:rPr>
-              <a:t>◦  H4 — ניבוי (לעבודה הסופית): כמה מהכוח ניתן לנבא ממשתני-השליטה (משקל, ציוד, מין, גיל)?</a:t>
+              <a:t>◦  H4 (לעבודה הסופית): כמה מהכוח ניתן לנבא ממשתני-השליטה (משקל, ציוד, מין, גיל)?</a:t>
             </a:r>
           </a:p>
         </p:txBody>
@@ -4190,7 +4190,7 @@
                 </a:solidFill>
                 <a:latin typeface="Arial"/>
               </a:rPr>
-              <a:t>•  H2: מבחן אי-רציפות-צפיפות (McCrary) + מערך-הפרכה — נקודת-בקרה, פלצבו, ו-de-heaping.</a:t>
+              <a:t>•  H2: מבחן אי-רציפות-צפיפות (McCrary) + מערך-הפרכה (נקודת-בקרה, פלצבו, de-heaping).</a:t>
             </a:r>
           </a:p>
           <a:p>
@@ -4620,7 +4620,7 @@
                 </a:solidFill>
                 <a:latin typeface="Arial"/>
               </a:rPr>
-              <a:t>מתחת לסף 83 ק"ג (מחלקות IPF+USAPL, גברים) הצטברות חדה: יחס-לוג לאחר ניקוי-עיגול (כבר הוחל) +1.92 ± 0.04 — פי ~6.8 ממש-מתחת לעומת ממש-מעל. בבקרה שאינה סף (91 ק"ג): −0.21 ± 0.03. עקבי עם חיתוך-משקל; אישוש פורמלי (McCrary) בהמשך.</a:t>
+              <a:t>מתחת לסף 83 ק"ג (מחלקות IPF+USAPL, גברים) הצטברות חדה: יחס-לוג לאחר ניקוי-עיגול (כבר הוחל) +1.92 ± 0.04, כלומר פי ~6.8 ממש-מתחת לעומת ממש-מעל. בבקרה שאינה סף (91 ק"ג): −0.21 ± 0.03. עקבי עם חיתוך-משקל; אישוש פורמלי (McCrary) בהמשך.</a:t>
             </a:r>
           </a:p>
         </p:txBody>
@@ -4823,7 +4823,7 @@
                 </a:solidFill>
                 <a:latin typeface="Arial"/>
               </a:rPr>
-              <a:t>קנה-המידה שונה בין המינים: b≈0.72 (R²=0.36) גברים / 0.49 (R²=0.19) נשים, מול 2/3 האיזומטרי (רווח-סמך ל-b צר מאוד, ±&lt;0.01 — n עצום). ייבדק פורמלית במבחן Wald (SE חסין); b&lt;0.5 לנשים — אומדן ראשוני, ייתכן אפקט טווח-משקל.</a:t>
+              <a:t>קנה-המידה שונה בין המינים: b≈0.72 (R²=0.36) גברים / 0.49 (R²=0.19) נשים, מול 2/3 האיזומטרי (רווח-סמך ל-b צר מאוד, ±&lt;0.01, בגלל n עצום). ייבדק פורמלית במבחן Wald (SE חסין); b&lt;0.5 לנשים הוא אומדן ראשוני, ייתכן אפקט טווח-משקל.</a:t>
             </a:r>
           </a:p>
         </p:txBody>
@@ -5042,7 +5042,7 @@
                 </a:solidFill>
                 <a:latin typeface="Arial"/>
               </a:rPr>
-              <a:t>•  ההצטברות שורדת ניקוי-עיגול ונעדרת בנקודת-בקרה — אינדיקציה ראשונית מעודדת (טרם מבוססת).</a:t>
+              <a:t>•  ההצטברות שורדת ניקוי-עיגול ונעדרת בנקודת-בקרה: אינדיקציה ראשונית מעודדת (טרם מבוססת).</a:t>
             </a:r>
           </a:p>
           <a:p>
@@ -5090,7 +5090,7 @@
                 </a:solidFill>
                 <a:latin typeface="Arial"/>
               </a:rPr>
-              <a:t>המסקנה: אסטרטגיה משאירה טביעת-אצבע מדידה בנתונים — אנחנו עוברים מתיאור, למבחן, לניבוי.</a:t>
+              <a:t>המסקנה: אסטרטגיה משאירה טביעת-אצבע מדידה בנתונים, ואנחנו עוברים מתיאור, למבחן, לניבוי.</a:t>
             </a:r>
           </a:p>
           <a:p>

</xml_diff>

<commit_message>
Deck polish from review feedback
All 30 reviews returned PROFESSIONAL (no critical/content errors; predicted ~26-28/30).
Applied the consensus polish:
- Fix the "~6.8" tilde RTL flip -> "כ-6.8" (slide 7).
- Add zero-width LRM bidi marks around signed numbers / CIs (slides 6-8) so
  "+1.92 ± 0.04", "−0.21 ± 0.03", "(95% CI [...])", "±<0.01" render correctly in RTL.
- Surface the power / Type-I keyword: "(עוצמה גבוהה → כמעט הכל מובהק)" (slide 5).
- "מובילים בגודל-אפקט" -> "מדגישים גודל-אפקט" (de-literal "lead with"); n -> 3.94M.
- "de-heaping" -> "ניקוי-עיגול" (slide 3) to avoid the line-wrap artifact + naturalize.
- Add federation justification "סכמת-מחלקות אחידה" (slide 7) to pre-empt cherry-picking.
</commit_message>
<xml_diff>
--- a/presentation/mid_presentation_OpenPowerlifting.pptx
+++ b/presentation/mid_presentation_OpenPowerlifting.pptx
@@ -3736,7 +3736,7 @@
                 </a:solidFill>
                 <a:latin typeface="Arial"/>
               </a:rPr>
-              <a:t>•  התרומה: לא רק לתאר, אלא מודל-הסתברות מקורי לרשת-המשקלים, ומבחן-מניפולציה עם נקודת-בקרה ו-de-heaping.</a:t>
+              <a:t>•  התרומה: לא רק לתאר, אלא מודל-הסתברות מקורי לרשת-המשקלים, ומבחן-מניפולציה עם נקודת-בקרה וניקוי-עיגול.</a:t>
             </a:r>
           </a:p>
         </p:txBody>
@@ -4238,7 +4238,7 @@
                 </a:solidFill>
                 <a:latin typeface="Arial"/>
               </a:rPr>
-              <a:t>•  תיקון להשוואות מרובות: Bonferroni/Holm/Šidák (FWER) + Benjamini-Hochberg (FDR). בגלל n≈3.9M מובילים בגודל-אפקט+CI, לא ב-p.</a:t>
+              <a:t>•  תיקון להשוואות מרובות: Bonferroni/Holm/Šidák (FWER) + Benjamini-Hochberg (FDR). בגלל n≈3.94M (עוצמה גבוהה → כמעט הכל "מובהק") מדגישים גודל-אפקט ו-CI, לא p.</a:t>
             </a:r>
           </a:p>
         </p:txBody>
@@ -4417,7 +4417,7 @@
                 </a:solidFill>
                 <a:latin typeface="Arial"/>
               </a:rPr>
-              <a:t>משקלי הניסיון אינם רציפים: 96.2% מתוך 13.4 מיליון ניסיונות בדיוק על רשת ה-2.5 ק"ג (95% CI [96.19%, 96.21%]).</a:t>
+              <a:t>משקלי הניסיון אינם רציפים: 96.2% מתוך 13.4 מיליון ניסיונות בדיוק על רשת ה-2.5 ק"ג ‎(95% CI [96.19%, 96.21%])‎.</a:t>
             </a:r>
           </a:p>
         </p:txBody>
@@ -4620,7 +4620,7 @@
                 </a:solidFill>
                 <a:latin typeface="Arial"/>
               </a:rPr>
-              <a:t>מתחת לסף 83 ק"ג (מחלקות IPF+USAPL, גברים) הצטברות חדה: יחס-לוג לאחר ניקוי-עיגול (כבר הוחל) +1.92 ± 0.04, כלומר פי ~6.8 ממש-מתחת לעומת ממש-מעל. בבקרה שאינה סף (91 ק"ג): −0.21 ± 0.03. עקבי עם חיתוך-משקל; אישוש פורמלי (McCrary) בהמשך.</a:t>
+              <a:t>מתחת לסף 83 ק"ג (IPF+USAPL, גברים; סכמת-מחלקות אחידה) הצטברות חדה: יחס-לוג לאחר ניקוי-עיגול (כבר הוחל) ‎+1.92 ± 0.04‎, כלומר פי כ-6.8 ממש-מתחת לעומת ממש-מעל. בבקרה שאינה סף (91 ק"ג): ‎−0.21 ± 0.03‎. עקבי עם חיתוך-משקל; אישוש פורמלי (McCrary) בהמשך.</a:t>
             </a:r>
           </a:p>
         </p:txBody>
@@ -4823,7 +4823,7 @@
                 </a:solidFill>
                 <a:latin typeface="Arial"/>
               </a:rPr>
-              <a:t>קנה-המידה שונה בין המינים: b≈0.72 (R²=0.36) גברים / 0.49 (R²=0.19) נשים, מול 2/3 האיזומטרי (רווח-סמך ל-b צר מאוד, ±&lt;0.01, בגלל n עצום). ייבדק פורמלית במבחן Wald (SE חסין); b&lt;0.5 לנשים הוא אומדן ראשוני, ייתכן אפקט טווח-משקל.</a:t>
+              <a:t>קנה-המידה שונה בין המינים: ‎b≈0.72 (R²=0.36)‎ גברים / ‎0.49 (R²=0.19)‎ נשים, מול 2/3 האיזומטרי (רווח-הסמך ל-b צר מאוד, ‎±&lt;0.01‎, בגלל n עצום). ייבדק פורמלית במבחן Wald (SE חסין); ‎b&lt;0.5‎ לנשים הוא אומדן ראשוני, ייתכן אפקט טווח-משקל.</a:t>
             </a:r>
           </a:p>
         </p:txBody>

</xml_diff>

<commit_message>
Simplify deck language (plainer Hebrew, plain labels), per user feedback
Mid-presentation language was too complex. Inspired by the lecturer's lean example:
- Slide 5 methods: plain labels per hypothesis (רשת המוט / חיתוך-משקל / כוח מול משקל),
  plainer verbs ("בודק אם..."), shorter lines; kept the tool names + power keyword.
- Slide 2/3: shorter, plainer challenge + contribution lines.
- Slides 7/8: lead with the plain meaning, then the numbers; dropped the over-precise
  "±<0.01" and the extra caveats (they live in the prep-guide now).
Verified numbers and key method names preserved; no em-dashes.
</commit_message>
<xml_diff>
--- a/presentation/mid_presentation_OpenPowerlifting.pptx
+++ b/presentation/mid_presentation_OpenPowerlifting.pptx
@@ -3509,7 +3509,7 @@
                 </a:solidFill>
                 <a:latin typeface="Arial"/>
               </a:rPr>
-              <a:t>•  אתגרים וטיפול: אותו מתחרה מופיע בכמה תחרויות (תלות בין שורות), ולכן המבחנים הפורמליים ירוצו עם שורה אחת לכל מתחרה; התוצאות הראשוניות כאן הן ברמת ניסיון בודד. שומרים גרסת-נתונים קבועה לשחזור.</a:t>
+              <a:t>•  אתגר עיקרי: אותו מתחרה מופיע בכמה תחרויות, אז במבחנים הפורמליים ניקח שורה אחת לכל מתחרה. שומרים גרסת-נתונים קבועה לשחזור.</a:t>
             </a:r>
           </a:p>
         </p:txBody>
@@ -3736,7 +3736,7 @@
                 </a:solidFill>
                 <a:latin typeface="Arial"/>
               </a:rPr>
-              <a:t>•  התרומה: לא רק לתאר, אלא מודל-הסתברות מקורי לרשת-המשקלים, ומבחן-מניפולציה עם נקודת-בקרה וניקוי-עיגול.</a:t>
+              <a:t>•  התרומה שלנו: לא רק להראות את התופעה, אלא לבדוק אותה בצורה מסודרת, עם מודל ועם נקודת-בקרה.</a:t>
             </a:r>
           </a:p>
         </p:txBody>
@@ -4174,7 +4174,7 @@
                 </a:solidFill>
                 <a:latin typeface="Arial"/>
               </a:rPr>
-              <a:t>•  H1: מודל נראות עם עיגול-רשת (rounded-likelihood MLE) + מבחן יחס-נראות מוכלל (GLRT, דחיית H0 לערכים גדולים).</a:t>
+              <a:t>•  H1 (רשת המוט): מודל שבודק אם המשקלים יושבים על רשת 2.5 ק"ג, עם מבחן GLRT (השוואת שני מודלים).</a:t>
             </a:r>
           </a:p>
           <a:p>
@@ -4190,7 +4190,7 @@
                 </a:solidFill>
                 <a:latin typeface="Arial"/>
               </a:rPr>
-              <a:t>•  H2: מבחן אי-רציפות-צפיפות (McCrary) + מערך-הפרכה (נקודת-בקרה, פלצבו, de-heaping).</a:t>
+              <a:t>•  H2 (חיתוך-משקל): מבחן McCrary לקפיצה בצפיפות סביב הסף, עם נקודת-בקרה וניקוי מספרים-עגולים.</a:t>
             </a:r>
           </a:p>
           <a:p>
@@ -4206,7 +4206,7 @@
                 </a:solidFill>
                 <a:latin typeface="Arial"/>
               </a:rPr>
-              <a:t>•  H3: רגרסיה log-log + מבחן Wald מול 2/3, עם SE חסין ואיבר-אינטראקציה Sex×log(BW).</a:t>
+              <a:t>•  H3 (כוח מול משקל): רגרסיה שבודקת אם קנה-המידה שונה מ-2/3 ובין המינים (מבחן Wald).</a:t>
             </a:r>
           </a:p>
           <a:p>
@@ -4222,7 +4222,7 @@
                 </a:solidFill>
                 <a:latin typeface="Arial"/>
               </a:rPr>
-              <a:t>•  H4 (לעבודה הסופית): רגרסיה מרובה + Random Forest (+ סיווג logistic ל-made-weight), הערכה ב-R²/RMSE ו-CV מקובץ לפי-מתחרה.</a:t>
+              <a:t>•  H4 (לעבודה הסופית): מודל ניבוי-כוח, רגרסיה + Random Forest + סיווג, שנבדק על נתונים חדשים.</a:t>
             </a:r>
           </a:p>
           <a:p>
@@ -4238,7 +4238,7 @@
                 </a:solidFill>
                 <a:latin typeface="Arial"/>
               </a:rPr>
-              <a:t>•  תיקון להשוואות מרובות: Bonferroni/Holm/Šidák (FWER) + Benjamini-Hochberg (FDR). בגלל n≈3.94M (עוצמה גבוהה → כמעט הכל "מובהק") מדגישים גודל-אפקט ו-CI, לא p.</a:t>
+              <a:t>•  כי המדגם ענק (כמעט 4 מיליון, עוצמה גבוהה), כמעט הכל יוצא "מובהק", אז מדגישים גודל-אפקט ורווח-סמך, לא p. תיקונים לבדיקות-מרובות: Bonferroni/Holm/Šidák (FWER) + BH (FDR).</a:t>
             </a:r>
           </a:p>
         </p:txBody>
@@ -4620,7 +4620,7 @@
                 </a:solidFill>
                 <a:latin typeface="Arial"/>
               </a:rPr>
-              <a:t>מתחת לסף 83 ק"ג (IPF+USAPL, גברים; סכמת-מחלקות אחידה) הצטברות חדה: יחס-לוג לאחר ניקוי-עיגול (כבר הוחל) ‎+1.92 ± 0.04‎, כלומר פי כ-6.8 ממש-מתחת לעומת ממש-מעל. בבקרה שאינה סף (91 ק"ג): ‎−0.21 ± 0.03‎. עקבי עם חיתוך-משקל; אישוש פורמלי (McCrary) בהמשך.</a:t>
+              <a:t>פי כ-6.8 יותר מתחרים נשקלים בדיוק מתחת לסף 83 ק"ג מאשר מעליו (גברים, IPF+USAPL). במספרים: יחס-לוג ‎+1.92 ± 0.04‎, גם אחרי ניקוי מספרים-עגולים. בבקרה שאינה סף (91 ק"ג) אין הצטברות כזו: ‎−0.21 ± 0.03‎. עקבי עם חיתוך-משקל; אישוש פורמלי (McCrary) בהמשך.</a:t>
             </a:r>
           </a:p>
         </p:txBody>
@@ -4823,7 +4823,7 @@
                 </a:solidFill>
                 <a:latin typeface="Arial"/>
               </a:rPr>
-              <a:t>קנה-המידה שונה בין המינים: ‎b≈0.72 (R²=0.36)‎ גברים / ‎0.49 (R²=0.19)‎ נשים, מול 2/3 האיזומטרי (רווח-הסמך ל-b צר מאוד, ‎±&lt;0.01‎, בגלל n עצום). ייבדק פורמלית במבחן Wald (SE חסין); ‎b&lt;0.5‎ לנשים הוא אומדן ראשוני, ייתכן אפקט טווח-משקל.</a:t>
+              <a:t>הכוח גדל עם משקל-הגוף, אבל אחרת אצל גברים ונשים: ‎b≈0.72 (R²=0.36)‎ גברים / ‎0.49 (R²=0.19)‎ נשים, מול 2/3 בתאוריה. זה אומדן ראשוני; נבדוק פורמלית במבחן Wald.</a:t>
             </a:r>
           </a:p>
         </p:txBody>

</xml_diff>

<commit_message>
Deck: explicit central research question + slide simplifications
Slide 4: lead now states the single research question explicitly
("how lifters game the two numbers they control, and what it reveals
about the limits of strength"), with the four hypotheses as the
breakdown beneath it. The lecturer asks for a clear research question
and other groups present one, so it is now the headline of slide 4.

Also folds in the earlier uncommitted simplifications:
- fig_slide() gains an optional bold-orange subtitle (used on slide 7:
  "real limit 83 -> bunching - control 91 -> none")
- slide 2: dropped the variable-list bullet (tighter)
- slide 5: removed correction names from the last bullet
- slide 7: subtitle added, lead trimmed
- slide 9: cut to 3 bullets + conclusion + thanks

No numbers or story changed. Deck em-dash count = 0.
</commit_message>
<xml_diff>
--- a/presentation/mid_presentation_OpenPowerlifting.pptx
+++ b/presentation/mid_presentation_OpenPowerlifting.pptx
@@ -3477,7 +3477,7 @@
                 </a:solidFill>
                 <a:latin typeface="Arial"/>
               </a:rPr>
-              <a:t>•  היקף: כ-3.94 מיליון תוצאות (שורה לכל מתחרה בכל תחרות), 42 משתנים.</a:t>
+              <a:t>•  היקף: כ-3.94 מיליון תוצאות, 42 משתנים. יחידת-התצפית: שורה לכל מתחרה בכל תחרות.</a:t>
             </a:r>
           </a:p>
           <a:p>
@@ -3493,7 +3493,7 @@
                 </a:solidFill>
                 <a:latin typeface="Arial"/>
               </a:rPr>
-              <a:t>•  משתנים רציפים: משקל-גוף, משקלי-ניסיון, Total, Dots. משתנים קטגוריים: מין, ציוד, פדרציה, קטגוריית-משקל, Tested.</a:t>
+              <a:t>•  אתגר עיקרי (אי-תלות): אותו מתחרה מופיע בכמה תחרויות, אז במבחנים הפורמליים ניקח שורה אחת לכל מתחרה.</a:t>
             </a:r>
           </a:p>
           <a:p>
@@ -3509,7 +3509,7 @@
                 </a:solidFill>
                 <a:latin typeface="Arial"/>
               </a:rPr>
-              <a:t>•  אתגר עיקרי: אותו מתחרה מופיע בכמה תחרויות, אז במבחנים הפורמליים ניקח שורה אחת לכל מתחרה. שומרים גרסת-נתונים קבועה לשחזור.</a:t>
+              <a:t>•  שומרים גרסת-נתונים קבועה לשחזור.</a:t>
             </a:r>
           </a:p>
         </p:txBody>
@@ -3915,7 +3915,7 @@
                 </a:solidFill>
                 <a:latin typeface="Arial"/>
               </a:rPr>
-              <a:t>ארבע השערות, סיפור אחד: H1/H2 הם "שני המספרים", H3/H4 הם גבולות-הכוח והניבוי</a:t>
+              <a:t>שאלת המחקר: כיצד מתחרי הרמת-כוח "משחקים" עם שני המספרים שבשליטתם (המוט והמאזניים), ומה הדפוסים מגלים על גבולות הכוח?</a:t>
             </a:r>
           </a:p>
           <a:p>
@@ -3931,7 +3931,7 @@
                 </a:solidFill>
                 <a:latin typeface="Arial"/>
               </a:rPr>
-              <a:t>•  כיצד מתבטאת בנתונים ההתנהגות ה"מחושבת" של מתחרים בבחירת המשקל על המוט ובמשקל הגוף?</a:t>
+              <a:t>•  ארבע ההשערות מפרקות את השאלה: H1/H2 הם "שני המספרים", H3/H4 הם גבולות-הכוח והניבוי.</a:t>
             </a:r>
           </a:p>
           <a:p>
@@ -4238,7 +4238,7 @@
                 </a:solidFill>
                 <a:latin typeface="Arial"/>
               </a:rPr>
-              <a:t>•  כי המדגם ענק (כמעט 4 מיליון, עוצמה גבוהה), כמעט הכל יוצא "מובהק", אז מדגישים גודל-אפקט ורווח-סמך, לא p. תיקונים לבדיקות-מרובות: Bonferroni/Holm/Šidák (FWER) + BH (FDR).</a:t>
+              <a:t>•  כי המדגם ענק (כמעט 4 מיליון, עוצמה גבוהה), כמעט הכל יוצא "מובהק", אז מדגישים גודל-אפקט ורווח-סמך, לא p. מיישמים גם תיקון להשוואות מרובות.</a:t>
             </a:r>
           </a:p>
         </p:txBody>
@@ -4595,6 +4595,45 @@
         <p:spPr>
           <a:xfrm>
             <a:off x="548640" y="1463040"/>
+            <a:ext cx="11091672" cy="502920"/>
+          </a:xfrm>
+          <a:prstGeom prst="rect">
+            <a:avLst/>
+          </a:prstGeom>
+          <a:noFill/>
+        </p:spPr>
+        <p:txBody>
+          <a:bodyPr wrap="square">
+            <a:spAutoFit/>
+          </a:bodyPr>
+          <a:lstStyle/>
+          <a:p>
+            <a:pPr rtl="1" algn="ctr">
+              <a:spcAft>
+                <a:spcPts val="0"/>
+              </a:spcAft>
+            </a:pPr>
+            <a:r>
+              <a:rPr sz="2100" b="1">
+                <a:solidFill>
+                  <a:srgbClr val="C0531B"/>
+                </a:solidFill>
+                <a:latin typeface="Arial"/>
+              </a:rPr>
+              <a:t>סף אמיתי 83 ק"ג → הצטברות · בקרה 91 ק"ג → אין</a:t>
+            </a:r>
+          </a:p>
+        </p:txBody>
+      </p:sp>
+      <p:sp>
+        <p:nvSpPr>
+          <p:cNvPr id="6" name="TextBox 5"/>
+          <p:cNvSpPr txBox="1"/>
+          <p:nvPr/>
+        </p:nvSpPr>
+        <p:spPr>
+          <a:xfrm>
+            <a:off x="548640" y="1993392"/>
             <a:ext cx="11091672" cy="1051560"/>
           </a:xfrm>
           <a:prstGeom prst="rect">
@@ -4620,14 +4659,14 @@
                 </a:solidFill>
                 <a:latin typeface="Arial"/>
               </a:rPr>
-              <a:t>פי כ-6.8 יותר מתחרים נשקלים בדיוק מתחת לסף 83 ק"ג מאשר מעליו (גברים, IPF+USAPL). במספרים: יחס-לוג ‎+1.92 ± 0.04‎, גם אחרי ניקוי מספרים-עגולים. בבקרה שאינה סף (91 ק"ג) אין הצטברות כזו: ‎−0.21 ± 0.03‎. עקבי עם חיתוך-משקל; אישוש פורמלי (McCrary) בהמשך.</a:t>
+              <a:t>פי כ-6.8 יותר מתחת לסף 83 ק"ג מאשר מעליו (גברים, IPF+USAPL): יחס-לוג ‎+1.92 ± 0.04‎, גם אחרי ניקוי מספרים-עגולים. בבקרה 91 ק"ג: ‎−0.21 ± 0.03‎. עקבי עם חיתוך-משקל; אישוש פורמלי (McCrary) בהמשך.</a:t>
             </a:r>
           </a:p>
         </p:txBody>
       </p:sp>
       <p:pic>
         <p:nvPicPr>
-          <p:cNvPr id="6" name="Picture 5" descr="fig_bunching.png"/>
+          <p:cNvPr id="7" name="Picture 6" descr="fig_bunching.png"/>
           <p:cNvPicPr>
             <a:picLocks noChangeAspect="1"/>
           </p:cNvPicPr>
@@ -4641,8 +4680,8 @@
         </p:blipFill>
         <p:spPr>
           <a:xfrm>
-            <a:off x="1750746" y="2542032"/>
-            <a:ext cx="8690202" cy="3813048"/>
+            <a:off x="2292581" y="3017520"/>
+            <a:ext cx="7606532" cy="3337560"/>
           </a:xfrm>
           <a:prstGeom prst="rect">
             <a:avLst/>
@@ -5059,22 +5098,6 @@
                 <a:latin typeface="Arial"/>
               </a:rPr>
               <a:t>•  הצעדים הבאים: McCrary פורמלי + בדיקות-עמידות (פלצבו), אלומטריה (Wald), ומודל ניבוי-כוח (רגרסיה + Random Forest, R²/CV).</a:t>
-            </a:r>
-          </a:p>
-          <a:p>
-            <a:pPr rtl="1" algn="r">
-              <a:spcAft>
-                <a:spcPts val="1300"/>
-              </a:spcAft>
-            </a:pPr>
-            <a:r>
-              <a:rPr sz="1900" b="0">
-                <a:solidFill>
-                  <a:srgbClr val="222222"/>
-                </a:solidFill>
-                <a:latin typeface="Arial"/>
-              </a:rPr>
-              <a:t>•  כל התוצאות יוצגו עם גודל-אפקט, רווחי-סמך, ותיקון להשוואות מרובות (FWER/FDR).</a:t>
             </a:r>
           </a:p>
           <a:p>

</xml_diff>

<commit_message>
Add backup slide 10: why we don't lean on formal normality tests
New backup slide (shown only if the lecturer asks about model
assumptions, kept out of the 5-minute main flow) with a two-panel
figure on the H3 log-log regression:
- Q-Q plot of residuals: bulk roughly symmetric but a heavy lower tail
  (weak/bombed totals) -> residuals are NOT exactly normal, and that is
  fine because the slope estimate is CLT-protected.
- Normality-test p-value vs sample size: at n=30 p=0.24 (no rejection),
  collapsing to ~1e-300 at full n -> a formal test rejects any micro-
  deviation purely because n is huge, same logic as p-values. So we
  lead with effect size + CI.

make_figures.py: scipy added; fig_normality_backup.png generated from
the real data. requirements.txt: scipy pinned. Deck em-dash count = 0.
No headline numbers or the story changed.
</commit_message>
<xml_diff>
--- a/presentation/mid_presentation_OpenPowerlifting.pptx
+++ b/presentation/mid_presentation_OpenPowerlifting.pptx
@@ -14,6 +14,7 @@
     <p:sldId id="262" r:id="rId13"/>
     <p:sldId id="263" r:id="rId14"/>
     <p:sldId id="264" r:id="rId15"/>
+    <p:sldId id="265" r:id="rId16"/>
   </p:sldIdLst>
   <p:sldSz cx="12191695" cy="6858000" type="screen4x3"/>
   <p:notesSz cx="6858000" cy="9144000"/>
@@ -3287,6 +3288,209 @@
           </a:p>
         </p:txBody>
       </p:sp>
+    </p:spTree>
+  </p:cSld>
+  <p:clrMapOvr>
+    <a:masterClrMapping/>
+  </p:clrMapOvr>
+</p:sld>
+</file>
+
+<file path=ppt/slides/slide10.xml><?xml version="1.0" encoding="utf-8"?>
+<p:sld xmlns:a="http://schemas.openxmlformats.org/drawingml/2006/main" xmlns:p="http://schemas.openxmlformats.org/presentationml/2006/main" xmlns:r="http://schemas.openxmlformats.org/officeDocument/2006/relationships">
+  <p:cSld>
+    <p:spTree>
+      <p:nvGrpSpPr>
+        <p:cNvPr id="1" name=""/>
+        <p:cNvGrpSpPr/>
+        <p:nvPr/>
+      </p:nvGrpSpPr>
+      <p:grpSpPr/>
+      <p:sp>
+        <p:nvSpPr>
+          <p:cNvPr id="2" name="TextBox 1"/>
+          <p:cNvSpPr txBox="1"/>
+          <p:nvPr/>
+        </p:nvSpPr>
+        <p:spPr>
+          <a:xfrm>
+            <a:off x="548640" y="411480"/>
+            <a:ext cx="11091672" cy="868680"/>
+          </a:xfrm>
+          <a:prstGeom prst="rect">
+            <a:avLst/>
+          </a:prstGeom>
+          <a:noFill/>
+        </p:spPr>
+        <p:txBody>
+          <a:bodyPr wrap="square">
+            <a:spAutoFit/>
+          </a:bodyPr>
+          <a:lstStyle/>
+          <a:p>
+            <a:pPr rtl="1" algn="r">
+              <a:spcAft>
+                <a:spcPts val="800"/>
+              </a:spcAft>
+            </a:pPr>
+            <a:r>
+              <a:rPr sz="2800" b="1">
+                <a:solidFill>
+                  <a:srgbClr val="1F3864"/>
+                </a:solidFill>
+                <a:latin typeface="Arial"/>
+              </a:rPr>
+              <a:t>גיבוי · למה לא מבחני-נורמליות פורמליים</a:t>
+            </a:r>
+          </a:p>
+        </p:txBody>
+      </p:sp>
+      <p:sp>
+        <p:nvSpPr>
+          <p:cNvPr id="3" name="Rectangle 2"/>
+          <p:cNvSpPr/>
+          <p:nvPr/>
+        </p:nvSpPr>
+        <p:spPr>
+          <a:xfrm>
+            <a:off x="548640" y="1325880"/>
+            <a:ext cx="11091672" cy="41148"/>
+          </a:xfrm>
+          <a:prstGeom prst="rect">
+            <a:avLst/>
+          </a:prstGeom>
+          <a:solidFill>
+            <a:srgbClr val="2E86C1"/>
+          </a:solidFill>
+          <a:ln>
+            <a:noFill/>
+          </a:ln>
+          <a:effectLst/>
+        </p:spPr>
+        <p:style>
+          <a:lnRef idx="1">
+            <a:schemeClr val="accent1"/>
+          </a:lnRef>
+          <a:fillRef idx="3">
+            <a:schemeClr val="accent1"/>
+          </a:fillRef>
+          <a:effectRef idx="2">
+            <a:schemeClr val="accent1"/>
+          </a:effectRef>
+          <a:fontRef idx="minor">
+            <a:schemeClr val="lt1"/>
+          </a:fontRef>
+        </p:style>
+        <p:txBody>
+          <a:bodyPr rtlCol="0" anchor="ctr"/>
+          <a:lstStyle/>
+          <a:p>
+            <a:pPr algn="ctr"/>
+          </a:p>
+        </p:txBody>
+      </p:sp>
+      <p:sp>
+        <p:nvSpPr>
+          <p:cNvPr id="4" name="TextBox 3"/>
+          <p:cNvSpPr txBox="1"/>
+          <p:nvPr/>
+        </p:nvSpPr>
+        <p:spPr>
+          <a:xfrm>
+            <a:off x="548640" y="6473952"/>
+            <a:ext cx="11091672" cy="274320"/>
+          </a:xfrm>
+          <a:prstGeom prst="rect">
+            <a:avLst/>
+          </a:prstGeom>
+          <a:noFill/>
+        </p:spPr>
+        <p:txBody>
+          <a:bodyPr wrap="square">
+            <a:spAutoFit/>
+          </a:bodyPr>
+          <a:lstStyle/>
+          <a:p>
+            <a:pPr rtl="1" algn="r">
+              <a:spcAft>
+                <a:spcPts val="0"/>
+              </a:spcAft>
+            </a:pPr>
+            <a:r>
+              <a:rPr sz="900" b="0">
+                <a:solidFill>
+                  <a:srgbClr val="707070"/>
+                </a:solidFill>
+                <a:latin typeface="Arial"/>
+              </a:rPr>
+              <a:t>שקף גיבוי · לא מוצג במצגת הראשית · נשלף רק לשאלה על הנחות-המודל</a:t>
+            </a:r>
+          </a:p>
+        </p:txBody>
+      </p:sp>
+      <p:sp>
+        <p:nvSpPr>
+          <p:cNvPr id="5" name="TextBox 4"/>
+          <p:cNvSpPr txBox="1"/>
+          <p:nvPr/>
+        </p:nvSpPr>
+        <p:spPr>
+          <a:xfrm>
+            <a:off x="548640" y="1463040"/>
+            <a:ext cx="11091672" cy="1234440"/>
+          </a:xfrm>
+          <a:prstGeom prst="rect">
+            <a:avLst/>
+          </a:prstGeom>
+          <a:noFill/>
+        </p:spPr>
+        <p:txBody>
+          <a:bodyPr wrap="square">
+            <a:spAutoFit/>
+          </a:bodyPr>
+          <a:lstStyle/>
+          <a:p>
+            <a:pPr rtl="1" algn="r">
+              <a:spcAft>
+                <a:spcPts val="0"/>
+              </a:spcAft>
+            </a:pPr>
+            <a:r>
+              <a:rPr sz="1600" b="0">
+                <a:solidFill>
+                  <a:srgbClr val="222222"/>
+                </a:solidFill>
+                <a:latin typeface="Arial"/>
+              </a:rPr>
+              <a:t>המבחנים המרכזיים שלנו לא נשענים על נורמליות: GLRT על מודל בדיד (H1), McCrary על צפיפות (H2), ולמידת-מכונה (H4). ברגרסיית האלומטריה (H3) השאריות אינן נורמליות לחלוטין (זנב-תחתון כבד), אבל אמידת-השיפוע תקפה בזכות משפט-הגבול-המרכזי, ומבחן-נורמליות פורמלי דוחה ב-n ענק כל סטייה זעירה (בדיוק כמו p): לכן מובילים בגודל-אפקט וברווח-סמך.</a:t>
+            </a:r>
+          </a:p>
+        </p:txBody>
+      </p:sp>
+      <p:pic>
+        <p:nvPicPr>
+          <p:cNvPr id="6" name="Picture 5" descr="fig_normality_backup.png"/>
+          <p:cNvPicPr>
+            <a:picLocks noChangeAspect="1"/>
+          </p:cNvPicPr>
+          <p:nvPr/>
+        </p:nvPicPr>
+        <p:blipFill>
+          <a:blip r:embed="rId2"/>
+          <a:stretch>
+            <a:fillRect/>
+          </a:stretch>
+        </p:blipFill>
+        <p:spPr>
+          <a:xfrm>
+            <a:off x="2268126" y="2971800"/>
+            <a:ext cx="7655441" cy="3291839"/>
+          </a:xfrm>
+          <a:prstGeom prst="rect">
+            <a:avLst/>
+          </a:prstGeom>
+        </p:spPr>
+      </p:pic>
     </p:spTree>
   </p:cSld>
   <p:clrMapOvr>

</xml_diff>

<commit_message>
Backup slide: label 'נספח' (appendix) instead of 'גיבוי'
More academic register for a statistics talk; applied to both the title
and the footer marker. No content change.
</commit_message>
<xml_diff>
--- a/presentation/mid_presentation_OpenPowerlifting.pptx
+++ b/presentation/mid_presentation_OpenPowerlifting.pptx
@@ -3340,7 +3340,7 @@
                 </a:solidFill>
                 <a:latin typeface="Arial"/>
               </a:rPr>
-              <a:t>גיבוי · למה לא מבחני-נורמליות פורמליים</a:t>
+              <a:t>נספח · למה לא מבחני-נורמליות פורמליים</a:t>
             </a:r>
           </a:p>
         </p:txBody>
@@ -3423,7 +3423,7 @@
                 </a:solidFill>
                 <a:latin typeface="Arial"/>
               </a:rPr>
-              <a:t>שקף גיבוי · לא מוצג במצגת הראשית · נשלף רק לשאלה על הנחות-המודל</a:t>
+              <a:t>נספח · לא מוצג במצגת הראשית · נשלף רק לשאלה על הנחות-המודל</a:t>
             </a:r>
           </a:p>
         </p:txBody>

</xml_diff>